<commit_message>
Minor fixes and comments
</commit_message>
<xml_diff>
--- a/Courses/Software-Sciences/IT-Module-3-Web-Design/15-Website-Testing/15-Website-Testing.pptx
+++ b/Courses/Software-Sciences/IT-Module-3-Web-Design/15-Website-Testing/15-Website-Testing.pptx
@@ -268,6 +268,72 @@
 </p:cmAuthorLst>
 </file>
 
+<file path=ppt/comments/modernComment_3B5_FBAA3527.xml><?xml version="1.0" encoding="utf-8"?>
+<p188:cmLst xmlns:a="http://schemas.openxmlformats.org/drawingml/2006/main" xmlns:r="http://schemas.openxmlformats.org/officeDocument/2006/relationships" xmlns:p188="http://schemas.microsoft.com/office/powerpoint/2018/8/main">
+  <p188:cm id="{19497790-16B0-4643-8A12-EA28BC45B708}" authorId="{CB4BF2F8-D32F-9387-A6CE-368ED6EFDCF0}" created="2026-08-03T15:23:09.241">
+    <ac:deMkLst xmlns:ac="http://schemas.microsoft.com/office/drawing/2013/main/command">
+      <pc:docMk xmlns:pc="http://schemas.microsoft.com/office/powerpoint/2013/main/command"/>
+      <pc:sldMk xmlns:pc="http://schemas.microsoft.com/office/powerpoint/2013/main/command" cId="4222235943" sldId="949"/>
+      <ac:picMk id="6" creationId="{EC1E0A6B-1000-8C92-56F3-790379ABBC43}"/>
+    </ac:deMkLst>
+    <p188:txBody>
+      <a:bodyPr/>
+      <a:lstStyle/>
+      <a:p>
+        <a:r>
+          <a:rPr lang="en-GB"/>
+          <a:t>Направи before and after за редакцията, която се случва</a:t>
+        </a:r>
+      </a:p>
+    </p188:txBody>
+  </p188:cm>
+</p188:cmLst>
+</file>
+
+<file path=ppt/comments/modernComment_3B9_B4AA2873.xml><?xml version="1.0" encoding="utf-8"?>
+<p188:cmLst xmlns:a="http://schemas.openxmlformats.org/drawingml/2006/main" xmlns:r="http://schemas.openxmlformats.org/officeDocument/2006/relationships" xmlns:p188="http://schemas.microsoft.com/office/powerpoint/2018/8/main">
+  <p188:cm id="{98CE0964-97CF-49C7-9530-89ABD1376946}" authorId="{CB4BF2F8-D32F-9387-A6CE-368ED6EFDCF0}" created="2026-08-03T15:06:45.031">
+    <ac:deMkLst xmlns:ac="http://schemas.microsoft.com/office/drawing/2013/main/command">
+      <pc:docMk xmlns:pc="http://schemas.microsoft.com/office/powerpoint/2013/main/command"/>
+      <pc:sldMk xmlns:pc="http://schemas.microsoft.com/office/powerpoint/2013/main/command" cId="3031050355" sldId="953"/>
+      <ac:spMk id="3" creationId="{72337110-2C41-5B6A-8AD1-CDBAD0FD6C6F}"/>
+    </ac:deMkLst>
+    <p188:txBody>
+      <a:bodyPr/>
+      <a:lstStyle/>
+      <a:p>
+        <a:r>
+          <a:rPr lang="en-GB"/>
+          <a:t>Добави като фън факт откъде произлиза термина "бъг"</a:t>
+        </a:r>
+      </a:p>
+    </p188:txBody>
+  </p188:cm>
+</p188:cmLst>
+</file>
+
+<file path=ppt/comments/modernComment_3BF_C09AF3AE.xml><?xml version="1.0" encoding="utf-8"?>
+<p188:cmLst xmlns:a="http://schemas.openxmlformats.org/drawingml/2006/main" xmlns:r="http://schemas.openxmlformats.org/officeDocument/2006/relationships" xmlns:p188="http://schemas.microsoft.com/office/powerpoint/2018/8/main">
+  <p188:cm id="{0339C6D4-1141-4282-8F29-6EBD383B3094}" authorId="{CB4BF2F8-D32F-9387-A6CE-368ED6EFDCF0}" created="2026-08-03T15:19:11.497">
+    <ac:deMkLst xmlns:ac="http://schemas.microsoft.com/office/drawing/2013/main/command">
+      <pc:docMk xmlns:pc="http://schemas.microsoft.com/office/powerpoint/2013/main/command"/>
+      <pc:sldMk xmlns:pc="http://schemas.microsoft.com/office/powerpoint/2013/main/command" cId="3231380398" sldId="959"/>
+      <ac:spMk id="3" creationId="{8FF54D8E-052F-5AC2-D5A0-0F232910ECD6}"/>
+    </ac:deMkLst>
+    <p188:txBody>
+      <a:bodyPr/>
+      <a:lstStyle/>
+      <a:p>
+        <a:r>
+          <a:rPr lang="en-GB"/>
+          <a:t>Този слайд седи празен. Добави някоя снимка или разчупи по някакъв начин съдържанието</a:t>
+        </a:r>
+      </a:p>
+    </p188:txBody>
+  </p188:cm>
+</p188:cmLst>
+</file>
+
 <file path=ppt/handoutMasters/handoutMaster1.xml><?xml version="1.0" encoding="utf-8"?>
 <p:handoutMaster xmlns:a="http://schemas.openxmlformats.org/drawingml/2006/main" xmlns:r="http://schemas.openxmlformats.org/officeDocument/2006/relationships" xmlns:p="http://schemas.openxmlformats.org/presentationml/2006/main">
   <p:cSld>
@@ -362,7 +428,7 @@
           <a:p>
             <a:fld id="{4E087215-0C8F-4762-A664-737A353EC9A4}" type="datetimeFigureOut">
               <a:rPr lang="bg-BG" smtClean="0"/>
-              <a:t>29.06.26 г.</a:t>
+              <a:t>3.8.2026 г.</a:t>
             </a:fld>
             <a:endParaRPr lang="bg-BG"/>
           </a:p>
@@ -558,7 +624,7 @@
           <a:p>
             <a:fld id="{72D84649-876A-46C9-8472-14CB09C070D8}" type="datetimeFigureOut">
               <a:rPr lang="en-US" smtClean="0"/>
-              <a:t>6/29/26</a:t>
+              <a:t>8/3/2026</a:t>
             </a:fld>
             <a:endParaRPr lang="en-US"/>
           </a:p>
@@ -9535,7 +9601,7 @@
         </p:nvSpPr>
         <p:spPr>
           <a:xfrm>
-            <a:off x="2496000" y="1854174"/>
+            <a:off x="3049850" y="2138863"/>
             <a:ext cx="6750000" cy="3477875"/>
           </a:xfrm>
           <a:prstGeom prst="rect">
@@ -9778,7 +9844,7 @@
         </p:nvSpPr>
         <p:spPr bwMode="auto">
           <a:xfrm>
-            <a:off x="6217150" y="1299311"/>
+            <a:off x="6771000" y="1584000"/>
             <a:ext cx="3897700" cy="441116"/>
           </a:xfrm>
           <a:prstGeom prst="wedgeRoundRectCallout">
@@ -9960,7 +10026,7 @@
         </p:nvSpPr>
         <p:spPr bwMode="auto">
           <a:xfrm>
-            <a:off x="6433500" y="2949074"/>
+            <a:off x="6987350" y="3233763"/>
             <a:ext cx="3465000" cy="441116"/>
           </a:xfrm>
           <a:prstGeom prst="wedgeRoundRectCallout">
@@ -10058,13 +10124,13 @@
         </p:nvSpPr>
         <p:spPr bwMode="auto">
           <a:xfrm>
-            <a:off x="8910784" y="3699445"/>
-            <a:ext cx="3025400" cy="441116"/>
+            <a:off x="744256" y="3537433"/>
+            <a:ext cx="2205000" cy="882653"/>
           </a:xfrm>
           <a:prstGeom prst="wedgeRoundRectCallout">
             <a:avLst>
-              <a:gd name="adj1" fmla="val -58779"/>
-              <a:gd name="adj2" fmla="val 75737"/>
+              <a:gd name="adj1" fmla="val 67883"/>
+              <a:gd name="adj2" fmla="val 49838"/>
               <a:gd name="adj3" fmla="val 16667"/>
             </a:avLst>
           </a:prstGeom>
@@ -10189,7 +10255,7 @@
         </p:nvSpPr>
         <p:spPr bwMode="auto">
           <a:xfrm>
-            <a:off x="4795325" y="5133338"/>
+            <a:off x="5349175" y="5418027"/>
             <a:ext cx="2601350" cy="441116"/>
           </a:xfrm>
           <a:prstGeom prst="wedgeRoundRectCallout">
@@ -10287,7 +10353,7 @@
         </p:nvSpPr>
         <p:spPr bwMode="auto">
           <a:xfrm>
-            <a:off x="3171000" y="4385164"/>
+            <a:off x="3724850" y="4669853"/>
             <a:ext cx="2205000" cy="247500"/>
           </a:xfrm>
           <a:prstGeom prst="rect">
@@ -10394,7 +10460,7 @@
         </p:nvSpPr>
         <p:spPr bwMode="auto">
           <a:xfrm>
-            <a:off x="4256305" y="3763422"/>
+            <a:off x="4810155" y="4048111"/>
             <a:ext cx="722230" cy="247500"/>
           </a:xfrm>
           <a:prstGeom prst="rect">
@@ -10471,7 +10537,7 @@
         </p:nvSpPr>
         <p:spPr bwMode="auto">
           <a:xfrm>
-            <a:off x="5542260" y="4072521"/>
+            <a:off x="6096110" y="4357210"/>
             <a:ext cx="3025400" cy="255767"/>
           </a:xfrm>
           <a:prstGeom prst="rect">
@@ -10568,7 +10634,7 @@
         </p:nvSpPr>
         <p:spPr bwMode="auto">
           <a:xfrm>
-            <a:off x="2516860" y="1941163"/>
+            <a:off x="3070710" y="2225852"/>
             <a:ext cx="3025400" cy="541796"/>
           </a:xfrm>
           <a:prstGeom prst="rect">
@@ -17915,6 +17981,10 @@
               <a:rPr lang="bg-BG" dirty="0"/>
               <a:t>Чести грешки</a:t>
             </a:r>
+            <a:r>
+              <a:rPr lang="en-GB" dirty="0"/>
+              <a:t> (1)</a:t>
+            </a:r>
             <a:endParaRPr lang="en-BG" dirty="0"/>
           </a:p>
         </p:txBody>
@@ -18084,7 +18154,7 @@
         <p:spPr>
           <a:xfrm>
             <a:off x="651000" y="4734000"/>
-            <a:ext cx="5100200" cy="461665"/>
+            <a:ext cx="5625000" cy="461665"/>
           </a:xfrm>
           <a:prstGeom prst="rect">
             <a:avLst/>
@@ -18112,21 +18182,38 @@
           <a:lstStyle/>
           <a:p>
             <a:r>
-              <a:rPr lang="en-GB" sz="2400" b="1" dirty="0">
+              <a:rPr lang="en-GB" sz="2400" b="1" dirty="0" err="1">
                 <a:solidFill>
                   <a:schemeClr val="bg1"/>
                 </a:solidFill>
                 <a:latin typeface="Consolas" panose="020B0609020204030204" pitchFamily="49" charset="0"/>
                 <a:cs typeface="Consolas" panose="020B0609020204030204" pitchFamily="49" charset="0"/>
               </a:rPr>
-              <a:t>src="</a:t>
+              <a:t>src</a:t>
+            </a:r>
+            <a:r>
+              <a:rPr lang="en-GB" sz="2400" b="1" dirty="0">
+                <a:solidFill>
+                  <a:schemeClr val="bg1"/>
+                </a:solidFill>
+                <a:latin typeface="Consolas" panose="020B0609020204030204" pitchFamily="49" charset="0"/>
+                <a:cs typeface="Consolas" panose="020B0609020204030204" pitchFamily="49" charset="0"/>
+              </a:rPr>
+              <a:t>="</a:t>
+            </a:r>
+            <a:r>
+              <a:rPr lang="en-GB" sz="2400" b="1" dirty="0" err="1">
+                <a:latin typeface="Consolas" panose="020B0609020204030204" pitchFamily="49" charset="0"/>
+                <a:cs typeface="Consolas" panose="020B0609020204030204" pitchFamily="49" charset="0"/>
+              </a:rPr>
+              <a:t>unexisting</a:t>
             </a:r>
             <a:r>
               <a:rPr lang="en-GB" sz="2400" b="1" dirty="0">
                 <a:latin typeface="Consolas" panose="020B0609020204030204" pitchFamily="49" charset="0"/>
                 <a:cs typeface="Consolas" panose="020B0609020204030204" pitchFamily="49" charset="0"/>
               </a:rPr>
-              <a:t>img/photo.jpg</a:t>
+              <a:t>-path/photo.jpg</a:t>
             </a:r>
             <a:r>
               <a:rPr lang="en-GB" sz="2400" b="1" dirty="0">
@@ -18145,101 +18232,6 @@
               <a:latin typeface="Consolas" panose="020B0609020204030204" pitchFamily="49" charset="0"/>
               <a:ea typeface="Courier New" pitchFamily="34" charset="-122"/>
               <a:cs typeface="Consolas" panose="020B0609020204030204" pitchFamily="49" charset="0"/>
-            </a:endParaRPr>
-          </a:p>
-        </p:txBody>
-      </p:sp>
-      <p:sp>
-        <p:nvSpPr>
-          <p:cNvPr id="8" name="Rounded Rectangular Callout 7">
-            <a:extLst>
-              <a:ext uri="{FF2B5EF4-FFF2-40B4-BE49-F238E27FC236}">
-                <a16:creationId xmlns:a16="http://schemas.microsoft.com/office/drawing/2014/main" id="{9935B3E9-79BE-6F73-54BC-B50CB35B36BC}"/>
-              </a:ext>
-            </a:extLst>
-          </p:cNvPr>
-          <p:cNvSpPr/>
-          <p:nvPr/>
-        </p:nvSpPr>
-        <p:spPr bwMode="auto">
-          <a:xfrm>
-            <a:off x="5154298" y="4839666"/>
-            <a:ext cx="2115000" cy="498658"/>
-          </a:xfrm>
-          <a:prstGeom prst="wedgeRoundRectCallout">
-            <a:avLst>
-              <a:gd name="adj1" fmla="val -109239"/>
-              <a:gd name="adj2" fmla="val -14397"/>
-              <a:gd name="adj3" fmla="val 16667"/>
-            </a:avLst>
-          </a:prstGeom>
-          <a:solidFill>
-            <a:schemeClr val="dk2">
-              <a:alpha val="80000"/>
-            </a:schemeClr>
-          </a:solidFill>
-          <a:ln w="19050">
-            <a:solidFill>
-              <a:schemeClr val="tx1">
-                <a:lumMod val="75000"/>
-                <a:alpha val="80000"/>
-              </a:schemeClr>
-            </a:solidFill>
-          </a:ln>
-          <a:effectLst/>
-        </p:spPr>
-        <p:style>
-          <a:lnRef idx="2">
-            <a:schemeClr val="accent1">
-              <a:shade val="50000"/>
-            </a:schemeClr>
-          </a:lnRef>
-          <a:fillRef idx="1001">
-            <a:schemeClr val="dk2"/>
-          </a:fillRef>
-          <a:effectRef idx="0">
-            <a:schemeClr val="accent1"/>
-          </a:effectRef>
-          <a:fontRef idx="minor">
-            <a:schemeClr val="lt1"/>
-          </a:fontRef>
-        </p:style>
-        <p:txBody>
-          <a:bodyPr rot="0" spcFirstLastPara="0" vertOverflow="overflow" horzOverflow="overflow" vert="horz" wrap="square" lIns="91440" tIns="45720" rIns="91440" bIns="45720" numCol="1" spcCol="0" rtlCol="0" fromWordArt="0" anchor="ctr" anchorCtr="0" forceAA="0" compatLnSpc="1">
-            <a:prstTxWarp prst="textNoShape">
-              <a:avLst/>
-            </a:prstTxWarp>
-            <a:noAutofit/>
-          </a:bodyPr>
-          <a:lstStyle/>
-          <a:p>
-            <a:pPr algn="ctr"/>
-            <a:r>
-              <a:rPr lang="bg-BG" sz="2600" b="1" dirty="0">
-                <a:solidFill>
-                  <a:schemeClr val="bg2"/>
-                </a:solidFill>
-                <a:effectLst>
-                  <a:outerShdw blurRad="38100" dist="38100" dir="2700000" algn="tl">
-                    <a:srgbClr val="000000">
-                      <a:alpha val="43137"/>
-                    </a:srgbClr>
-                  </a:outerShdw>
-                </a:effectLst>
-              </a:rPr>
-              <a:t>Грешен път</a:t>
-            </a:r>
-            <a:endParaRPr lang="en-BG" sz="2600" b="1" dirty="0">
-              <a:solidFill>
-                <a:schemeClr val="bg2"/>
-              </a:solidFill>
-              <a:effectLst>
-                <a:outerShdw blurRad="38100" dist="38100" dir="2700000" algn="tl">
-                  <a:srgbClr val="000000">
-                    <a:alpha val="43137"/>
-                  </a:srgbClr>
-                </a:outerShdw>
-              </a:effectLst>
             </a:endParaRPr>
           </a:p>
         </p:txBody>
@@ -18593,7 +18585,7 @@
                             </p:stCondLst>
                             <p:childTnLst>
                               <p:par>
-                                <p:cTn id="25" presetID="1" presetClass="entr" presetSubtype="0" fill="hold" grpId="0" nodeType="clickEffect">
+                                <p:cTn id="25" presetID="1" presetClass="entr" presetSubtype="0" fill="hold" nodeType="clickEffect">
                                   <p:stCondLst>
                                     <p:cond delay="0"/>
                                   </p:stCondLst>
@@ -18606,7 +18598,11 @@
                                           </p:stCondLst>
                                         </p:cTn>
                                         <p:tgtEl>
-                                          <p:spTgt spid="8"/>
+                                          <p:spTgt spid="3">
+                                            <p:txEl>
+                                              <p:pRg st="6" end="6"/>
+                                            </p:txEl>
+                                          </p:spTgt>
                                         </p:tgtEl>
                                         <p:attrNameLst>
                                           <p:attrName>style.visibility</p:attrName>
@@ -18638,7 +18634,7 @@
                             </p:stCondLst>
                             <p:childTnLst>
                               <p:par>
-                                <p:cTn id="29" presetID="1" presetClass="entr" presetSubtype="0" fill="hold" nodeType="clickEffect">
+                                <p:cTn id="29" presetID="1" presetClass="entr" presetSubtype="0" fill="hold" grpId="0" nodeType="clickEffect">
                                   <p:stCondLst>
                                     <p:cond delay="0"/>
                                   </p:stCondLst>
@@ -18646,55 +18642,6 @@
                                     <p:set>
                                       <p:cBhvr>
                                         <p:cTn id="30" dur="1" fill="hold">
-                                          <p:stCondLst>
-                                            <p:cond delay="0"/>
-                                          </p:stCondLst>
-                                        </p:cTn>
-                                        <p:tgtEl>
-                                          <p:spTgt spid="3">
-                                            <p:txEl>
-                                              <p:pRg st="6" end="6"/>
-                                            </p:txEl>
-                                          </p:spTgt>
-                                        </p:tgtEl>
-                                        <p:attrNameLst>
-                                          <p:attrName>style.visibility</p:attrName>
-                                        </p:attrNameLst>
-                                      </p:cBhvr>
-                                      <p:to>
-                                        <p:strVal val="visible"/>
-                                      </p:to>
-                                    </p:set>
-                                  </p:childTnLst>
-                                </p:cTn>
-                              </p:par>
-                            </p:childTnLst>
-                          </p:cTn>
-                        </p:par>
-                      </p:childTnLst>
-                    </p:cTn>
-                  </p:par>
-                  <p:par>
-                    <p:cTn id="31" fill="hold">
-                      <p:stCondLst>
-                        <p:cond delay="indefinite"/>
-                      </p:stCondLst>
-                      <p:childTnLst>
-                        <p:par>
-                          <p:cTn id="32" fill="hold">
-                            <p:stCondLst>
-                              <p:cond delay="0"/>
-                            </p:stCondLst>
-                            <p:childTnLst>
-                              <p:par>
-                                <p:cTn id="33" presetID="1" presetClass="entr" presetSubtype="0" fill="hold" grpId="0" nodeType="clickEffect">
-                                  <p:stCondLst>
-                                    <p:cond delay="0"/>
-                                  </p:stCondLst>
-                                  <p:childTnLst>
-                                    <p:set>
-                                      <p:cBhvr>
-                                        <p:cTn id="34" dur="1" fill="hold">
                                           <p:stCondLst>
                                             <p:cond delay="0"/>
                                           </p:stCondLst>
@@ -18744,7 +18691,6 @@
       <p:bldP spid="5" grpId="0" animBg="1"/>
       <p:bldP spid="6" grpId="0" animBg="1"/>
       <p:bldP spid="7" grpId="0" animBg="1"/>
-      <p:bldP spid="8" grpId="0" animBg="1"/>
       <p:bldP spid="9" grpId="0" animBg="1"/>
     </p:bldLst>
   </p:timing>
@@ -18964,6 +18910,10 @@
             <a:r>
               <a:rPr lang="bg-BG" dirty="0"/>
               <a:t>Чести грешки</a:t>
+            </a:r>
+            <a:r>
+              <a:rPr lang="en-GB" dirty="0"/>
+              <a:t> (2)</a:t>
             </a:r>
             <a:endParaRPr lang="en-BG" dirty="0"/>
           </a:p>
@@ -22138,6 +22088,11 @@
       </p:par>
     </p:tnLst>
   </p:timing>
+  <p:extLst>
+    <p:ext uri="{6950BFC3-D8DA-4A85-94F7-54DA5524770B}">
+      <p188:commentRel xmlns:p188="http://schemas.microsoft.com/office/powerpoint/2018/8/main" r:id="rId2"/>
+    </p:ext>
+  </p:extLst>
 </p:sld>
 </file>
 
@@ -22546,6 +22501,281 @@
       <p:transition spd="slow" advClick="0" advTm="5000"/>
     </mc:Fallback>
   </mc:AlternateContent>
+  <p:timing>
+    <p:tnLst>
+      <p:par>
+        <p:cTn id="1" dur="indefinite" restart="never" nodeType="tmRoot">
+          <p:childTnLst>
+            <p:seq concurrent="1" nextAc="seek">
+              <p:cTn id="2" dur="indefinite" nodeType="mainSeq">
+                <p:childTnLst>
+                  <p:par>
+                    <p:cTn id="3" fill="hold">
+                      <p:stCondLst>
+                        <p:cond delay="indefinite"/>
+                      </p:stCondLst>
+                      <p:childTnLst>
+                        <p:par>
+                          <p:cTn id="4" fill="hold">
+                            <p:stCondLst>
+                              <p:cond delay="0"/>
+                            </p:stCondLst>
+                            <p:childTnLst>
+                              <p:par>
+                                <p:cTn id="5" presetID="1" presetClass="entr" presetSubtype="0" fill="hold" nodeType="clickEffect">
+                                  <p:stCondLst>
+                                    <p:cond delay="0"/>
+                                  </p:stCondLst>
+                                  <p:childTnLst>
+                                    <p:set>
+                                      <p:cBhvr>
+                                        <p:cTn id="6" dur="1" fill="hold">
+                                          <p:stCondLst>
+                                            <p:cond delay="0"/>
+                                          </p:stCondLst>
+                                        </p:cTn>
+                                        <p:tgtEl>
+                                          <p:spTgt spid="3">
+                                            <p:txEl>
+                                              <p:pRg st="1" end="1"/>
+                                            </p:txEl>
+                                          </p:spTgt>
+                                        </p:tgtEl>
+                                        <p:attrNameLst>
+                                          <p:attrName>style.visibility</p:attrName>
+                                        </p:attrNameLst>
+                                      </p:cBhvr>
+                                      <p:to>
+                                        <p:strVal val="visible"/>
+                                      </p:to>
+                                    </p:set>
+                                  </p:childTnLst>
+                                </p:cTn>
+                              </p:par>
+                            </p:childTnLst>
+                          </p:cTn>
+                        </p:par>
+                      </p:childTnLst>
+                    </p:cTn>
+                  </p:par>
+                  <p:par>
+                    <p:cTn id="7" fill="hold">
+                      <p:stCondLst>
+                        <p:cond delay="indefinite"/>
+                      </p:stCondLst>
+                      <p:childTnLst>
+                        <p:par>
+                          <p:cTn id="8" fill="hold">
+                            <p:stCondLst>
+                              <p:cond delay="0"/>
+                            </p:stCondLst>
+                            <p:childTnLst>
+                              <p:par>
+                                <p:cTn id="9" presetID="1" presetClass="entr" presetSubtype="0" fill="hold" nodeType="clickEffect">
+                                  <p:stCondLst>
+                                    <p:cond delay="0"/>
+                                  </p:stCondLst>
+                                  <p:childTnLst>
+                                    <p:set>
+                                      <p:cBhvr>
+                                        <p:cTn id="10" dur="1" fill="hold">
+                                          <p:stCondLst>
+                                            <p:cond delay="0"/>
+                                          </p:stCondLst>
+                                        </p:cTn>
+                                        <p:tgtEl>
+                                          <p:spTgt spid="3">
+                                            <p:txEl>
+                                              <p:pRg st="2" end="2"/>
+                                            </p:txEl>
+                                          </p:spTgt>
+                                        </p:tgtEl>
+                                        <p:attrNameLst>
+                                          <p:attrName>style.visibility</p:attrName>
+                                        </p:attrNameLst>
+                                      </p:cBhvr>
+                                      <p:to>
+                                        <p:strVal val="visible"/>
+                                      </p:to>
+                                    </p:set>
+                                  </p:childTnLst>
+                                </p:cTn>
+                              </p:par>
+                            </p:childTnLst>
+                          </p:cTn>
+                        </p:par>
+                      </p:childTnLst>
+                    </p:cTn>
+                  </p:par>
+                  <p:par>
+                    <p:cTn id="11" fill="hold">
+                      <p:stCondLst>
+                        <p:cond delay="indefinite"/>
+                      </p:stCondLst>
+                      <p:childTnLst>
+                        <p:par>
+                          <p:cTn id="12" fill="hold">
+                            <p:stCondLst>
+                              <p:cond delay="0"/>
+                            </p:stCondLst>
+                            <p:childTnLst>
+                              <p:par>
+                                <p:cTn id="13" presetID="1" presetClass="entr" presetSubtype="0" fill="hold" nodeType="clickEffect">
+                                  <p:stCondLst>
+                                    <p:cond delay="0"/>
+                                  </p:stCondLst>
+                                  <p:childTnLst>
+                                    <p:set>
+                                      <p:cBhvr>
+                                        <p:cTn id="14" dur="1" fill="hold">
+                                          <p:stCondLst>
+                                            <p:cond delay="0"/>
+                                          </p:stCondLst>
+                                        </p:cTn>
+                                        <p:tgtEl>
+                                          <p:spTgt spid="3">
+                                            <p:txEl>
+                                              <p:pRg st="3" end="3"/>
+                                            </p:txEl>
+                                          </p:spTgt>
+                                        </p:tgtEl>
+                                        <p:attrNameLst>
+                                          <p:attrName>style.visibility</p:attrName>
+                                        </p:attrNameLst>
+                                      </p:cBhvr>
+                                      <p:to>
+                                        <p:strVal val="visible"/>
+                                      </p:to>
+                                    </p:set>
+                                  </p:childTnLst>
+                                </p:cTn>
+                              </p:par>
+                            </p:childTnLst>
+                          </p:cTn>
+                        </p:par>
+                      </p:childTnLst>
+                    </p:cTn>
+                  </p:par>
+                  <p:par>
+                    <p:cTn id="15" fill="hold">
+                      <p:stCondLst>
+                        <p:cond delay="indefinite"/>
+                      </p:stCondLst>
+                      <p:childTnLst>
+                        <p:par>
+                          <p:cTn id="16" fill="hold">
+                            <p:stCondLst>
+                              <p:cond delay="0"/>
+                            </p:stCondLst>
+                            <p:childTnLst>
+                              <p:par>
+                                <p:cTn id="17" presetID="1" presetClass="entr" presetSubtype="0" fill="hold" nodeType="clickEffect">
+                                  <p:stCondLst>
+                                    <p:cond delay="0"/>
+                                  </p:stCondLst>
+                                  <p:childTnLst>
+                                    <p:set>
+                                      <p:cBhvr>
+                                        <p:cTn id="18" dur="1" fill="hold">
+                                          <p:stCondLst>
+                                            <p:cond delay="0"/>
+                                          </p:stCondLst>
+                                        </p:cTn>
+                                        <p:tgtEl>
+                                          <p:spTgt spid="3">
+                                            <p:txEl>
+                                              <p:pRg st="4" end="4"/>
+                                            </p:txEl>
+                                          </p:spTgt>
+                                        </p:tgtEl>
+                                        <p:attrNameLst>
+                                          <p:attrName>style.visibility</p:attrName>
+                                        </p:attrNameLst>
+                                      </p:cBhvr>
+                                      <p:to>
+                                        <p:strVal val="visible"/>
+                                      </p:to>
+                                    </p:set>
+                                  </p:childTnLst>
+                                </p:cTn>
+                              </p:par>
+                            </p:childTnLst>
+                          </p:cTn>
+                        </p:par>
+                      </p:childTnLst>
+                    </p:cTn>
+                  </p:par>
+                  <p:par>
+                    <p:cTn id="19" fill="hold">
+                      <p:stCondLst>
+                        <p:cond delay="indefinite"/>
+                      </p:stCondLst>
+                      <p:childTnLst>
+                        <p:par>
+                          <p:cTn id="20" fill="hold">
+                            <p:stCondLst>
+                              <p:cond delay="0"/>
+                            </p:stCondLst>
+                            <p:childTnLst>
+                              <p:par>
+                                <p:cTn id="21" presetID="1" presetClass="entr" presetSubtype="0" fill="hold" nodeType="clickEffect">
+                                  <p:stCondLst>
+                                    <p:cond delay="0"/>
+                                  </p:stCondLst>
+                                  <p:childTnLst>
+                                    <p:set>
+                                      <p:cBhvr>
+                                        <p:cTn id="22" dur="1" fill="hold">
+                                          <p:stCondLst>
+                                            <p:cond delay="0"/>
+                                          </p:stCondLst>
+                                        </p:cTn>
+                                        <p:tgtEl>
+                                          <p:spTgt spid="3">
+                                            <p:txEl>
+                                              <p:pRg st="5" end="5"/>
+                                            </p:txEl>
+                                          </p:spTgt>
+                                        </p:tgtEl>
+                                        <p:attrNameLst>
+                                          <p:attrName>style.visibility</p:attrName>
+                                        </p:attrNameLst>
+                                      </p:cBhvr>
+                                      <p:to>
+                                        <p:strVal val="visible"/>
+                                      </p:to>
+                                    </p:set>
+                                  </p:childTnLst>
+                                </p:cTn>
+                              </p:par>
+                            </p:childTnLst>
+                          </p:cTn>
+                        </p:par>
+                      </p:childTnLst>
+                    </p:cTn>
+                  </p:par>
+                </p:childTnLst>
+              </p:cTn>
+              <p:prevCondLst>
+                <p:cond evt="onPrev" delay="0">
+                  <p:tgtEl>
+                    <p:sldTgt/>
+                  </p:tgtEl>
+                </p:cond>
+              </p:prevCondLst>
+              <p:nextCondLst>
+                <p:cond evt="onNext" delay="0">
+                  <p:tgtEl>
+                    <p:sldTgt/>
+                  </p:tgtEl>
+                </p:cond>
+              </p:nextCondLst>
+            </p:seq>
+          </p:childTnLst>
+        </p:cTn>
+      </p:par>
+    </p:tnLst>
+  </p:timing>
 </p:sld>
 </file>
 
@@ -22809,7 +23039,7 @@
                   <a:schemeClr val="bg1"/>
                 </a:solidFill>
               </a:rPr>
-              <a:t>HTML </a:t>
+              <a:t>index.html </a:t>
             </a:r>
             <a:r>
               <a:rPr lang="bg-BG" sz="2800" b="1" dirty="0">
@@ -25311,7 +25541,7 @@
           <p:nvPr/>
         </p:nvPicPr>
         <p:blipFill>
-          <a:blip r:embed="rId2" cstate="email">
+          <a:blip r:embed="rId3" cstate="email">
             <a:extLst>
               <a:ext uri="{28A0092B-C50C-407E-A947-70E740481C1C}">
                 <a14:useLocalDpi xmlns:a14="http://schemas.microsoft.com/office/drawing/2010/main"/>
@@ -25407,7 +25637,7 @@
           <p:nvPr/>
         </p:nvPicPr>
         <p:blipFill rotWithShape="1">
-          <a:blip r:embed="rId3" cstate="email">
+          <a:blip r:embed="rId4" cstate="email">
             <a:extLst>
               <a:ext uri="{28A0092B-C50C-407E-A947-70E740481C1C}">
                 <a14:useLocalDpi xmlns:a14="http://schemas.microsoft.com/office/drawing/2010/main"/>
@@ -25718,6 +25948,11 @@
       <p:bldP spid="9" grpId="0" animBg="1"/>
     </p:bldLst>
   </p:timing>
+  <p:extLst>
+    <p:ext uri="{6950BFC3-D8DA-4A85-94F7-54DA5524770B}">
+      <p188:commentRel xmlns:p188="http://schemas.microsoft.com/office/powerpoint/2018/8/main" r:id="rId2"/>
+    </p:ext>
+  </p:extLst>
 </p:sld>
 </file>
 
@@ -28987,6 +29222,232 @@
       <p:transition spd="slow" advClick="0" advTm="5000"/>
     </mc:Fallback>
   </mc:AlternateContent>
+  <p:timing>
+    <p:tnLst>
+      <p:par>
+        <p:cTn id="1" dur="indefinite" restart="never" nodeType="tmRoot">
+          <p:childTnLst>
+            <p:seq concurrent="1" nextAc="seek">
+              <p:cTn id="2" dur="indefinite" nodeType="mainSeq">
+                <p:childTnLst>
+                  <p:par>
+                    <p:cTn id="3" fill="hold">
+                      <p:stCondLst>
+                        <p:cond delay="indefinite"/>
+                      </p:stCondLst>
+                      <p:childTnLst>
+                        <p:par>
+                          <p:cTn id="4" fill="hold">
+                            <p:stCondLst>
+                              <p:cond delay="0"/>
+                            </p:stCondLst>
+                            <p:childTnLst>
+                              <p:par>
+                                <p:cTn id="5" presetID="1" presetClass="entr" presetSubtype="0" fill="hold" nodeType="clickEffect">
+                                  <p:stCondLst>
+                                    <p:cond delay="0"/>
+                                  </p:stCondLst>
+                                  <p:childTnLst>
+                                    <p:set>
+                                      <p:cBhvr>
+                                        <p:cTn id="6" dur="1" fill="hold">
+                                          <p:stCondLst>
+                                            <p:cond delay="0"/>
+                                          </p:stCondLst>
+                                        </p:cTn>
+                                        <p:tgtEl>
+                                          <p:spTgt spid="14">
+                                            <p:txEl>
+                                              <p:pRg st="1" end="1"/>
+                                            </p:txEl>
+                                          </p:spTgt>
+                                        </p:tgtEl>
+                                        <p:attrNameLst>
+                                          <p:attrName>style.visibility</p:attrName>
+                                        </p:attrNameLst>
+                                      </p:cBhvr>
+                                      <p:to>
+                                        <p:strVal val="visible"/>
+                                      </p:to>
+                                    </p:set>
+                                  </p:childTnLst>
+                                </p:cTn>
+                              </p:par>
+                            </p:childTnLst>
+                          </p:cTn>
+                        </p:par>
+                      </p:childTnLst>
+                    </p:cTn>
+                  </p:par>
+                  <p:par>
+                    <p:cTn id="7" fill="hold">
+                      <p:stCondLst>
+                        <p:cond delay="indefinite"/>
+                      </p:stCondLst>
+                      <p:childTnLst>
+                        <p:par>
+                          <p:cTn id="8" fill="hold">
+                            <p:stCondLst>
+                              <p:cond delay="0"/>
+                            </p:stCondLst>
+                            <p:childTnLst>
+                              <p:par>
+                                <p:cTn id="9" presetID="1" presetClass="entr" presetSubtype="0" fill="hold" nodeType="clickEffect">
+                                  <p:stCondLst>
+                                    <p:cond delay="0"/>
+                                  </p:stCondLst>
+                                  <p:childTnLst>
+                                    <p:set>
+                                      <p:cBhvr>
+                                        <p:cTn id="10" dur="1" fill="hold">
+                                          <p:stCondLst>
+                                            <p:cond delay="0"/>
+                                          </p:stCondLst>
+                                        </p:cTn>
+                                        <p:tgtEl>
+                                          <p:spTgt spid="14">
+                                            <p:txEl>
+                                              <p:pRg st="2" end="2"/>
+                                            </p:txEl>
+                                          </p:spTgt>
+                                        </p:tgtEl>
+                                        <p:attrNameLst>
+                                          <p:attrName>style.visibility</p:attrName>
+                                        </p:attrNameLst>
+                                      </p:cBhvr>
+                                      <p:to>
+                                        <p:strVal val="visible"/>
+                                      </p:to>
+                                    </p:set>
+                                  </p:childTnLst>
+                                </p:cTn>
+                              </p:par>
+                            </p:childTnLst>
+                          </p:cTn>
+                        </p:par>
+                      </p:childTnLst>
+                    </p:cTn>
+                  </p:par>
+                  <p:par>
+                    <p:cTn id="11" fill="hold">
+                      <p:stCondLst>
+                        <p:cond delay="indefinite"/>
+                      </p:stCondLst>
+                      <p:childTnLst>
+                        <p:par>
+                          <p:cTn id="12" fill="hold">
+                            <p:stCondLst>
+                              <p:cond delay="0"/>
+                            </p:stCondLst>
+                            <p:childTnLst>
+                              <p:par>
+                                <p:cTn id="13" presetID="1" presetClass="entr" presetSubtype="0" fill="hold" nodeType="clickEffect">
+                                  <p:stCondLst>
+                                    <p:cond delay="0"/>
+                                  </p:stCondLst>
+                                  <p:childTnLst>
+                                    <p:set>
+                                      <p:cBhvr>
+                                        <p:cTn id="14" dur="1" fill="hold">
+                                          <p:stCondLst>
+                                            <p:cond delay="0"/>
+                                          </p:stCondLst>
+                                        </p:cTn>
+                                        <p:tgtEl>
+                                          <p:spTgt spid="14">
+                                            <p:txEl>
+                                              <p:pRg st="3" end="3"/>
+                                            </p:txEl>
+                                          </p:spTgt>
+                                        </p:tgtEl>
+                                        <p:attrNameLst>
+                                          <p:attrName>style.visibility</p:attrName>
+                                        </p:attrNameLst>
+                                      </p:cBhvr>
+                                      <p:to>
+                                        <p:strVal val="visible"/>
+                                      </p:to>
+                                    </p:set>
+                                  </p:childTnLst>
+                                </p:cTn>
+                              </p:par>
+                            </p:childTnLst>
+                          </p:cTn>
+                        </p:par>
+                      </p:childTnLst>
+                    </p:cTn>
+                  </p:par>
+                  <p:par>
+                    <p:cTn id="15" fill="hold">
+                      <p:stCondLst>
+                        <p:cond delay="indefinite"/>
+                      </p:stCondLst>
+                      <p:childTnLst>
+                        <p:par>
+                          <p:cTn id="16" fill="hold">
+                            <p:stCondLst>
+                              <p:cond delay="0"/>
+                            </p:stCondLst>
+                            <p:childTnLst>
+                              <p:par>
+                                <p:cTn id="17" presetID="1" presetClass="entr" presetSubtype="0" fill="hold" nodeType="clickEffect">
+                                  <p:stCondLst>
+                                    <p:cond delay="0"/>
+                                  </p:stCondLst>
+                                  <p:childTnLst>
+                                    <p:set>
+                                      <p:cBhvr>
+                                        <p:cTn id="18" dur="1" fill="hold">
+                                          <p:stCondLst>
+                                            <p:cond delay="0"/>
+                                          </p:stCondLst>
+                                        </p:cTn>
+                                        <p:tgtEl>
+                                          <p:spTgt spid="14">
+                                            <p:txEl>
+                                              <p:pRg st="4" end="4"/>
+                                            </p:txEl>
+                                          </p:spTgt>
+                                        </p:tgtEl>
+                                        <p:attrNameLst>
+                                          <p:attrName>style.visibility</p:attrName>
+                                        </p:attrNameLst>
+                                      </p:cBhvr>
+                                      <p:to>
+                                        <p:strVal val="visible"/>
+                                      </p:to>
+                                    </p:set>
+                                  </p:childTnLst>
+                                </p:cTn>
+                              </p:par>
+                            </p:childTnLst>
+                          </p:cTn>
+                        </p:par>
+                      </p:childTnLst>
+                    </p:cTn>
+                  </p:par>
+                </p:childTnLst>
+              </p:cTn>
+              <p:prevCondLst>
+                <p:cond evt="onPrev" delay="0">
+                  <p:tgtEl>
+                    <p:sldTgt/>
+                  </p:tgtEl>
+                </p:cond>
+              </p:prevCondLst>
+              <p:nextCondLst>
+                <p:cond evt="onNext" delay="0">
+                  <p:tgtEl>
+                    <p:sldTgt/>
+                  </p:tgtEl>
+                </p:cond>
+              </p:nextCondLst>
+            </p:seq>
+          </p:childTnLst>
+        </p:cTn>
+      </p:par>
+    </p:tnLst>
+  </p:timing>
 </p:sld>
 </file>
 
@@ -29662,7 +30123,15 @@
             </a:r>
             <a:r>
               <a:rPr lang="bg-BG" sz="3000" b="1" dirty="0"/>
-              <a:t>не работи </a:t>
+              <a:t>не работи</a:t>
+            </a:r>
+            <a:r>
+              <a:rPr lang="bg-BG" sz="3000" dirty="0"/>
+              <a:t>,</a:t>
+            </a:r>
+            <a:r>
+              <a:rPr lang="bg-BG" sz="3000" b="1" dirty="0"/>
+              <a:t> </a:t>
             </a:r>
             <a:r>
               <a:rPr lang="bg-BG" sz="3000" dirty="0"/>
@@ -29753,7 +30222,7 @@
           <p:nvPr/>
         </p:nvPicPr>
         <p:blipFill rotWithShape="1">
-          <a:blip r:embed="rId2" cstate="email">
+          <a:blip r:embed="rId3" cstate="email">
             <a:extLst>
               <a:ext uri="{28A0092B-C50C-407E-A947-70E740481C1C}">
                 <a14:useLocalDpi xmlns:a14="http://schemas.microsoft.com/office/drawing/2010/main"/>
@@ -30066,6 +30535,11 @@
       </p:par>
     </p:tnLst>
   </p:timing>
+  <p:extLst>
+    <p:ext uri="{6950BFC3-D8DA-4A85-94F7-54DA5524770B}">
+      <p188:commentRel xmlns:p188="http://schemas.microsoft.com/office/powerpoint/2018/8/main" r:id="rId2"/>
+    </p:ext>
+  </p:extLst>
 </p:sld>
 </file>
 
@@ -32521,9 +32995,9 @@
                                           </p:stCondLst>
                                         </p:cTn>
                                         <p:tgtEl>
-                                          <p:spTgt spid="7">
+                                          <p:spTgt spid="6">
                                             <p:txEl>
-                                              <p:pRg st="0" end="0"/>
+                                              <p:pRg st="1" end="1"/>
                                             </p:txEl>
                                           </p:spTgt>
                                         </p:tgtEl>
@@ -32570,7 +33044,7 @@
                                           </p:stCondLst>
                                         </p:cTn>
                                         <p:tgtEl>
-                                          <p:spTgt spid="6">
+                                          <p:spTgt spid="7">
                                             <p:txEl>
                                               <p:pRg st="1" end="1"/>
                                             </p:txEl>
@@ -32619,9 +33093,9 @@
                                           </p:stCondLst>
                                         </p:cTn>
                                         <p:tgtEl>
-                                          <p:spTgt spid="7">
+                                          <p:spTgt spid="6">
                                             <p:txEl>
-                                              <p:pRg st="1" end="1"/>
+                                              <p:pRg st="2" end="2"/>
                                             </p:txEl>
                                           </p:spTgt>
                                         </p:tgtEl>
@@ -32668,7 +33142,7 @@
                                           </p:stCondLst>
                                         </p:cTn>
                                         <p:tgtEl>
-                                          <p:spTgt spid="6">
+                                          <p:spTgt spid="7">
                                             <p:txEl>
                                               <p:pRg st="2" end="2"/>
                                             </p:txEl>
@@ -32717,9 +33191,9 @@
                                           </p:stCondLst>
                                         </p:cTn>
                                         <p:tgtEl>
-                                          <p:spTgt spid="7">
+                                          <p:spTgt spid="6">
                                             <p:txEl>
-                                              <p:pRg st="2" end="2"/>
+                                              <p:pRg st="3" end="3"/>
                                             </p:txEl>
                                           </p:spTgt>
                                         </p:tgtEl>
@@ -32766,7 +33240,7 @@
                                           </p:stCondLst>
                                         </p:cTn>
                                         <p:tgtEl>
-                                          <p:spTgt spid="6">
+                                          <p:spTgt spid="7">
                                             <p:txEl>
                                               <p:pRg st="3" end="3"/>
                                             </p:txEl>
@@ -32815,55 +33289,6 @@
                                           </p:stCondLst>
                                         </p:cTn>
                                         <p:tgtEl>
-                                          <p:spTgt spid="7">
-                                            <p:txEl>
-                                              <p:pRg st="3" end="3"/>
-                                            </p:txEl>
-                                          </p:spTgt>
-                                        </p:tgtEl>
-                                        <p:attrNameLst>
-                                          <p:attrName>style.visibility</p:attrName>
-                                        </p:attrNameLst>
-                                      </p:cBhvr>
-                                      <p:to>
-                                        <p:strVal val="visible"/>
-                                      </p:to>
-                                    </p:set>
-                                  </p:childTnLst>
-                                </p:cTn>
-                              </p:par>
-                            </p:childTnLst>
-                          </p:cTn>
-                        </p:par>
-                      </p:childTnLst>
-                    </p:cTn>
-                  </p:par>
-                  <p:par>
-                    <p:cTn id="31" fill="hold">
-                      <p:stCondLst>
-                        <p:cond delay="indefinite"/>
-                      </p:stCondLst>
-                      <p:childTnLst>
-                        <p:par>
-                          <p:cTn id="32" fill="hold">
-                            <p:stCondLst>
-                              <p:cond delay="0"/>
-                            </p:stCondLst>
-                            <p:childTnLst>
-                              <p:par>
-                                <p:cTn id="33" presetID="1" presetClass="entr" presetSubtype="0" fill="hold" nodeType="clickEffect">
-                                  <p:stCondLst>
-                                    <p:cond delay="0"/>
-                                  </p:stCondLst>
-                                  <p:childTnLst>
-                                    <p:set>
-                                      <p:cBhvr>
-                                        <p:cTn id="34" dur="1" fill="hold">
-                                          <p:stCondLst>
-                                            <p:cond delay="0"/>
-                                          </p:stCondLst>
-                                        </p:cTn>
-                                        <p:tgtEl>
                                           <p:spTgt spid="6">
                                             <p:txEl>
                                               <p:pRg st="4" end="4"/>
@@ -32882,14 +33307,14 @@
                                 </p:cTn>
                               </p:par>
                               <p:par>
-                                <p:cTn id="35" presetID="1" presetClass="entr" presetSubtype="0" fill="hold" nodeType="withEffect">
+                                <p:cTn id="31" presetID="1" presetClass="entr" presetSubtype="0" fill="hold" nodeType="withEffect">
                                   <p:stCondLst>
                                     <p:cond delay="0"/>
                                   </p:stCondLst>
                                   <p:childTnLst>
                                     <p:set>
                                       <p:cBhvr>
-                                        <p:cTn id="36" dur="1" fill="hold">
+                                        <p:cTn id="32" dur="1" fill="hold">
                                           <p:stCondLst>
                                             <p:cond delay="0"/>
                                           </p:stCondLst>
@@ -32919,26 +33344,26 @@
                     </p:cTn>
                   </p:par>
                   <p:par>
-                    <p:cTn id="37" fill="hold">
+                    <p:cTn id="33" fill="hold">
                       <p:stCondLst>
                         <p:cond delay="indefinite"/>
                       </p:stCondLst>
                       <p:childTnLst>
                         <p:par>
-                          <p:cTn id="38" fill="hold">
+                          <p:cTn id="34" fill="hold">
                             <p:stCondLst>
                               <p:cond delay="0"/>
                             </p:stCondLst>
                             <p:childTnLst>
                               <p:par>
-                                <p:cTn id="39" presetID="1" presetClass="entr" presetSubtype="0" fill="hold" nodeType="clickEffect">
+                                <p:cTn id="35" presetID="1" presetClass="entr" presetSubtype="0" fill="hold" nodeType="clickEffect">
                                   <p:stCondLst>
                                     <p:cond delay="0"/>
                                   </p:stCondLst>
                                   <p:childTnLst>
                                     <p:set>
                                       <p:cBhvr>
-                                        <p:cTn id="40" dur="1" fill="hold">
+                                        <p:cTn id="36" dur="1" fill="hold">
                                           <p:stCondLst>
                                             <p:cond delay="0"/>
                                           </p:stCondLst>
@@ -32962,14 +33387,14 @@
                                 </p:cTn>
                               </p:par>
                               <p:par>
-                                <p:cTn id="41" presetID="1" presetClass="entr" presetSubtype="0" fill="hold" nodeType="withEffect">
+                                <p:cTn id="37" presetID="1" presetClass="entr" presetSubtype="0" fill="hold" nodeType="withEffect">
                                   <p:stCondLst>
                                     <p:cond delay="0"/>
                                   </p:stCondLst>
                                   <p:childTnLst>
                                     <p:set>
                                       <p:cBhvr>
-                                        <p:cTn id="42" dur="1" fill="hold">
+                                        <p:cTn id="38" dur="1" fill="hold">
                                           <p:stCondLst>
                                             <p:cond delay="0"/>
                                           </p:stCondLst>

</xml_diff>